<commit_message>
Re-capture pr-files-changed from filtered URL (content commit only)
The original capture pointed at /pull/121/files (all commits view), which
showed 219 files dominated by the scaffolding commit's 200 figure copies.
That contradicts the chapter's whole point: reviewers should filter to
the content commit so they're not drowning in boilerplate.

The capture URL now includes the commit-range filter (85e53a4..7ae20224),
which renders the 'Commit 7ae2022' toolbar pill, the 4-file file tree
(preface, installation, gui, acronyms), and the 01-preface.mdx diff as
the first visible file. Updated fig-04 callouts and the storyboard GIF
base to match.
</commit_message>
<xml_diff>
--- a/planning/assets/figure-pptx/fig-04-pr-files-changed.pptx
+++ b/planning/assets/figure-pptx/fig-04-pr-files-changed.pptx
@@ -3216,8 +3216,8 @@
         </p:nvSpPr>
         <p:spPr>
           <a:xfrm>
-            <a:off x="361950" y="1009650"/>
-            <a:ext cx="1085850" cy="247649"/>
+            <a:off x="361950" y="981075"/>
+            <a:ext cx="1371600" cy="304800"/>
           </a:xfrm>
           <a:prstGeom prst="rect">
             <a:avLst/>
@@ -3259,7 +3259,7 @@
         </p:nvSpPr>
         <p:spPr>
           <a:xfrm>
-            <a:off x="190500" y="838200"/>
+            <a:off x="190500" y="809625"/>
             <a:ext cx="342900" cy="342900"/>
           </a:xfrm>
           <a:prstGeom prst="ellipse">
@@ -3313,7 +3313,7 @@
         <p:spPr>
           <a:xfrm>
             <a:off x="104775" y="1733550"/>
-            <a:ext cx="2847975" cy="2705100"/>
+            <a:ext cx="2847975" cy="1562100"/>
           </a:xfrm>
           <a:prstGeom prst="rect">
             <a:avLst/>
@@ -3408,8 +3408,8 @@
         </p:nvSpPr>
         <p:spPr>
           <a:xfrm>
-            <a:off x="3028950" y="1171575"/>
-            <a:ext cx="9563100" cy="561975"/>
+            <a:off x="3171825" y="3600450"/>
+            <a:ext cx="9420225" cy="561975"/>
           </a:xfrm>
           <a:prstGeom prst="rect">
             <a:avLst/>
@@ -3451,7 +3451,7 @@
         </p:nvSpPr>
         <p:spPr>
           <a:xfrm>
-            <a:off x="2857500" y="1000125"/>
+            <a:off x="3000375" y="3429000"/>
             <a:ext cx="342900" cy="342900"/>
           </a:xfrm>
           <a:prstGeom prst="ellipse">

</xml_diff>